<commit_message>
Kit Medicos: revisao interna das planilhas aplicada (25 achados) - cabecalho da 08, orcamentos coerentes, agenda com folga de 12 meses, provisao no DRE, repasse sem cobranca dupla, rotina 12/18, regras escritas; 677 verificacoes de coerencia OK
Co-Authored-By: Claude Opus 5 <noreply@anthropic.com>
Claude-Session: https://claude.ai/code/session_0146uBo6FVJ2cyEehyP8rK61
</commit_message>
<xml_diff>
--- a/projetos/gestao-ia-planilhas/produto/kit-medicos/27-modelo-resultado-do-mes-8-slides.pptx
+++ b/projetos/gestao-ia-planilhas/produto/kit-medicos/27-modelo-resultado-do-mes-8-slides.pptx
@@ -1096,7 +1096,7 @@
           <a:p>
             <a:r>
               <a:rPr lang="en-US" dirty="0"/>
-              <a:t>Kit de Gestão para Médicos · modelo v1.0 · set/2026 · Modelo do Kit de Gestão para Médicos (v1.0, set/2026): troque os textos e mantenha a estrutura. O símbolo do canto está no slide mestre (Exibir &gt; Slide mestre): apague lá uma vez e some de todos. Capa. A frase em itálico é a conclusão do mês em uma linha: escreva por último, depois de montar os outros slides. Os números vêm do Resultado mensal (18, Config = Agosto), do Caixa (09), da Agenda (01), do Simulador (07) e dos Convênios (13); a posição de parcelas e orçamentos é a de hoje (14 e 15). O prompt "Painel 01 · Explicar o mês ao sócio" ajuda a escrever a frase. Nenhum nome de paciente entra nesta apresentação.</a:t>
+              <a:t>Kit de Gestão para Médicos · modelo v1.0 · set/2026 · Modelo do Kit de Gestão para Médicos (v1.0, set/2026): troque os textos e mantenha a estrutura. O símbolo do canto está nos dois layouts, Claro e Escuro (Exibir &gt; Slide mestre): apague o símbolo nos dois e ele some de todos os slides. Capa. A frase em itálico é a conclusão do mês em uma linha: escreva por último, depois de montar os outros slides. Os números vêm do Resultado mensal (18, Config = Agosto), do Caixa (09), da Agenda (01), do Simulador (07) e dos Convênios (13); a posição de parcelas e orçamentos é a de hoje (14 e 15). O prompt "Painel 01 · Explicar o mês ao sócio" ajuda a escrever a frase. Nenhum nome de paciente entra nesta apresentação.</a:t>
             </a:r>
             <a:endParaRPr lang="en-US" dirty="0"/>
           </a:p>
@@ -1272,7 +1272,7 @@
           <a:p>
             <a:r>
               <a:rPr lang="en-US" dirty="0"/>
-              <a:t>Kit de Gestão para Médicos · modelo v1.0 · set/2026 · Agenda. Hoje, 14/09: setembro está em 81 % de ocupação, com a Sala 2 em 66 % (8,2 horas vazias) e 4 das 6 faltas do mês na agenda do Dr. Paulo; a taxa de falta caiu de 10,9 % (fim de julho) para 5,3 % depois da confirmação de véspera; os 48 retornos de agosto não têm cobrança. Os cartões vêm do Painel da 01 com Config = Agosto; a tabela, da Tabela de preços (08) com o volume de agosto. O ECG é o único procedimento com valor médio abaixo do mínimo: 13 dos 18 foram por convênio. Não discuta paciente nem atendimento aqui: só horas, faltas e valores.</a:t>
+              <a:t>Kit de Gestão para Médicos · modelo v1.0 · set/2026 · Agenda. Hoje, 14/09: setembro está em 81 % de ocupação, com a Sala 2 em 66 % (8,2 horas vazias) e 4 das 6 faltas do mês na agenda do Dr. Paulo; a taxa de falta caiu de 10,9 % (fim de julho) para 5,3 % depois da confirmação de véspera; os 48 retornos de agosto não têm cobrança. Os cartões vêm do Painel da 01 com Config = Agosto; a tabela, da Tabela de preços (08) com o volume de agosto. O ECG é o único procedimento com valor médio abaixo do mínimo: 10 dos 18 foram por convênio, a R$ 32 ou R$ 40. Não discuta paciente nem atendimento aqui: só horas, faltas e valores.</a:t>
             </a:r>
             <a:endParaRPr lang="en-US" dirty="0"/>
           </a:p>
@@ -9378,7 +9378,7 @@
                 <a:ea typeface="Arial" pitchFamily="34" charset="-122"/>
                 <a:cs typeface="Arial" pitchFamily="34" charset="-120"/>
               </a:rPr>
-              <a:t>Separar R$ 3.000 por mês para a reserva da clínica, a partir de setembro, até chegar a três meses de custo fixo (R$ 84.000; hoje R$ 14.000, meta em setembro de 2028 pela planilha 12). Ou R$ 5.000, pela sobra média dos últimos três meses?</a:t>
+              <a:t>Separar R$ 3.000 por mês para a reserva da clínica, a partir de setembro, até chegar a três meses de custo fixo (R$ 84.000; hoje R$ 14.000, meta em setembro de 2028 pela planilha 12). Ou R$ 5.000, que cabe na sobra média dos três últimos meses fechados (R$ 6.904)?</a:t>
             </a:r>
             <a:endParaRPr lang="en-US" sz="1300" dirty="0"/>
           </a:p>
@@ -9420,7 +9420,7 @@
                 <a:ea typeface="Arial" pitchFamily="34" charset="-122"/>
                 <a:cs typeface="Arial" pitchFamily="34" charset="-120"/>
               </a:rPr>
-              <a:t>Sala 2 com 8,2 horas vazias em setembro (66 % de ocupação). Abrir as tardes de segunda e quarta para um segundo médico parceiro por repasse (modelo 28), ou um turno a mais do Dr. Paulo? Decidir se a conversa começa.</a:t>
+              <a:t>Sala 2 com 8,2 horas vazias em setembro (66 % de ocupação). Abrir as tardes de segunda e quarta para um segundo médico parceiro por repasse (modelo 28)? Um turno a mais do Dr. Paulo só depois de encher os 34 % livres que ele já tem na Sala 2. Decidir se a conversa começa.</a:t>
             </a:r>
             <a:endParaRPr lang="en-US" sz="1300" dirty="0"/>
           </a:p>

</xml_diff>

<commit_message>
Kit Medicos: revisao interna dos documentos aplicada (24 achados) - prompt Caixa 03 criado (41 prompts), anexo do contador so com totais, ECG 10 de 18, blocos de prompt sem quebra, recortes legiveis, quem lanca o que, encarregado na LGPD; numeros realinhados ao NUMEROS.md novo
Co-Authored-By: Claude Opus 5 <noreply@anthropic.com>
Claude-Session: https://claude.ai/code/session_0146uBo6FVJ2cyEehyP8rK61
</commit_message>
<xml_diff>
--- a/projetos/gestao-ia-planilhas/produto/kit-medicos/27-modelo-resultado-do-mes-8-slides.pptx
+++ b/projetos/gestao-ia-planilhas/produto/kit-medicos/27-modelo-resultado-do-mes-8-slides.pptx
@@ -445,13 +445,13 @@
                 <c:formatCode>General</c:formatCode>
                 <c:ptCount val="3"/>
                 <c:pt idx="0">
-                  <c:v>43855</c:v>
+                  <c:v>44160</c:v>
                 </c:pt>
                 <c:pt idx="1">
-                  <c:v>53101</c:v>
+                  <c:v>53461</c:v>
                 </c:pt>
                 <c:pt idx="2">
-                  <c:v>50336</c:v>
+                  <c:v>49651</c:v>
                 </c:pt>
               </c:numCache>
             </c:numRef>
@@ -528,13 +528,13 @@
                 <c:formatCode>General</c:formatCode>
                 <c:ptCount val="3"/>
                 <c:pt idx="0">
-                  <c:v>41534</c:v>
+                  <c:v>41532</c:v>
                 </c:pt>
                 <c:pt idx="1">
-                  <c:v>43427</c:v>
+                  <c:v>43567</c:v>
                 </c:pt>
                 <c:pt idx="2">
-                  <c:v>41620</c:v>
+                  <c:v>41660</c:v>
                 </c:pt>
               </c:numCache>
             </c:numRef>
@@ -1184,7 +1184,7 @@
           <a:p>
             <a:r>
               <a:rPr lang="en-US" dirty="0"/>
-              <a:t>Kit de Gestão para Médicos · modelo v1.0 · set/2026 · Resumo. Três números: o que entrou, o que sobrou e o que ainda vai entrar. O card destacado é o resultado. Diga o número ruim junto com o bom. O resultado da DRE (18) não é o que sobrou no caixa (09: R$ 8.716): a DRE provisiona 11 % de impostos em vez da guia paga (R$ 5.841) e deixa fora a despesa pessoal a acertar (R$ 620, na 11).</a:t>
+              <a:t>Kit de Gestão para Médicos · modelo v1.0 · set/2026 · Resumo. Três números: o que entrou, o que sobrou e o que ainda vai entrar. O card destacado é o resultado. Diga o número ruim junto com o bom. O resultado da DRE (18) não é o que sobrou no caixa (09: R$ 7.991): a DRE provisiona 11 % de impostos em vez da guia paga (R$ 5.881), provisiona R$ 1.962 de 13º e férias que ainda não saíram do caixa e deixa fora a despesa pessoal a acertar (R$ 620, na 11).</a:t>
             </a:r>
             <a:endParaRPr lang="en-US" dirty="0"/>
           </a:p>
@@ -1448,7 +1448,7 @@
           <a:p>
             <a:r>
               <a:rPr lang="en-US" dirty="0"/>
-              <a:t>Kit de Gestão para Médicos · modelo v1.0 · set/2026 · Caixa. Gráfico de colunas nativo: Entrou e Saiu por mês; a diferença é o que sobrou. Os três meses vêm do Painel mensal do Caixa (09) ou da aba Histórico do Painel da clínica (17). Se o mês fechou negativo, diga primeiro e explique por quê. Julho teve a distribuição do 2º trimestre (R$ 3.591); agosto, a manutenção.</a:t>
+              <a:t>Kit de Gestão para Médicos · modelo v1.0 · set/2026 · Caixa. Gráfico de colunas nativo: Entrou e Saiu por mês; a diferença é o que sobrou. Os três meses vêm do Painel mensal do Caixa (09) ou da aba Histórico do Painel da clínica (17). Se o mês fechou negativo, diga primeiro e explique por quê. Julho teve a distribuição do 2º trimestre (R$ 3.697); agosto, a manutenção.</a:t>
             </a:r>
             <a:endParaRPr lang="en-US" dirty="0"/>
           </a:p>
@@ -2473,7 +2473,7 @@
                 <a:ea typeface="Arial" pitchFamily="34" charset="-122"/>
                 <a:cs typeface="Arial" pitchFamily="34" charset="-120"/>
               </a:rPr>
-              <a:t>Em uma frase: agosto deu resultado de R$ 9.640 (margem de 19,2 %), abaixo de julho; a ocupação de 70 % e os R$ 4.550 vencidos hoje pedem ação esta semana.</a:t>
+              <a:t>Em uma frase: agosto deu resultado de R$ 7.068 (margem de 14,2 %), abaixo de julho; a ocupação de 70 % e os R$ 3.775 vencidos hoje pedem ação esta semana.</a:t>
             </a:r>
             <a:endParaRPr lang="en-US" sz="1400" dirty="0"/>
           </a:p>
@@ -2646,7 +2646,7 @@
                 <a:ea typeface="Arial" pitchFamily="34" charset="-122"/>
                 <a:cs typeface="Arial" pitchFamily="34" charset="-120"/>
               </a:rPr>
-              <a:t>R$ 50.336</a:t>
+              <a:t>R$ 49.651</a:t>
             </a:r>
             <a:endParaRPr lang="en-US" sz="2600" dirty="0"/>
           </a:p>
@@ -2724,7 +2724,7 @@
                 <a:ea typeface="Arial" pitchFamily="34" charset="-122"/>
                 <a:cs typeface="Arial" pitchFamily="34" charset="-120"/>
               </a:rPr>
-              <a:t>R$ 53.101 em julho (−5,2 %). Particular à vista R$ 33.860, a prazo R$ 5.315, convênios R$ 11.161 (Saúde Total R$ 7.320, MediPlan R$ 2.130, Vida Care R$ 1.711).</a:t>
+              <a:t>R$ 53.461 em julho (−7,1 %). Particular à vista R$ 33.860, a prazo R$ 4.630, convênios R$ 11.161 (Saúde Total R$ 7.320, MediPlan R$ 2.130, Vida Care R$ 1.711).</a:t>
             </a:r>
             <a:endParaRPr lang="en-US" sz="1050" dirty="0"/>
           </a:p>
@@ -2792,7 +2792,7 @@
                 <a:ea typeface="Arial" pitchFamily="34" charset="-122"/>
                 <a:cs typeface="Arial" pitchFamily="34" charset="-120"/>
               </a:rPr>
-              <a:t>R$ 9.640</a:t>
+              <a:t>R$ 7.068</a:t>
             </a:r>
             <a:endParaRPr lang="en-US" sz="2600" dirty="0"/>
           </a:p>
@@ -2831,7 +2831,7 @@
                 <a:ea typeface="Arial" pitchFamily="34" charset="-122"/>
                 <a:cs typeface="Arial" pitchFamily="34" charset="-120"/>
               </a:rPr>
-              <a:t>Resultado (margem 19,2 %)</a:t>
+              <a:t>Resultado (margem 14,2 %)</a:t>
             </a:r>
             <a:endParaRPr lang="en-US" sz="1300" dirty="0"/>
           </a:p>
@@ -2870,7 +2870,7 @@
                 <a:ea typeface="Arial" pitchFamily="34" charset="-122"/>
                 <a:cs typeface="Arial" pitchFamily="34" charset="-120"/>
               </a:rPr>
-              <a:t>depois de R$ 10.000 de custos fixos, R$ 7.159 de despesas variáveis (materiais, cartão, repasse, manutenção), R$ 18.000 de pró-labore e R$ 5.537 de impostos provisionados (11 %). Julho: R$ 12.598 (23,7 %).</a:t>
+              <a:t>depois de R$ 10.000 de custos fixos, R$ 7.159 de despesas variáveis, R$ 18.000 de pró-labore, R$ 1.962 de provisão de 13º e férias e R$ 5.462 de impostos provisionados (11 %). Julho: R$ 10.956 (20,5 %).</a:t>
             </a:r>
             <a:endParaRPr lang="en-US" sz="1050" dirty="0"/>
           </a:p>
@@ -3016,7 +3016,7 @@
                 <a:ea typeface="Arial" pitchFamily="34" charset="-122"/>
                 <a:cs typeface="Arial" pitchFamily="34" charset="-120"/>
               </a:rPr>
-              <a:t>lotes enviados e não pagos, posição de 11/09; R$ 1.727 atrasados (lote de junho do Vida Care). Particulares: R$ 4.550 vencidos em 16 parcelas (inadimplência a prazo 10,4 %).</a:t>
+              <a:t>lotes enviados e não pagos, posição de 11/09; R$ 1.727 atrasados (lote de junho do Vida Care). Particulares: R$ 3.775 vencidos em 14 parcelas (inadimplência a prazo 9,4 %).</a:t>
             </a:r>
             <a:endParaRPr lang="en-US" sz="1050" dirty="0"/>
           </a:p>
@@ -8499,7 +8499,7 @@
                 <a:ea typeface="Arial" pitchFamily="34" charset="-122"/>
                 <a:cs typeface="Arial" pitchFamily="34" charset="-120"/>
               </a:rPr>
-              <a:t>Entrou R$ 50.336, saiu R$ 41.620, sobrou R$ 8.716 (julho: R$ 9.674; junho: R$ 2.321).</a:t>
+              <a:t>Entrou R$ 49.651, saiu R$ 41.660, sobrou R$ 7.991 (julho: R$ 9.894; junho: R$ 2.628).</a:t>
             </a:r>
             <a:endParaRPr lang="en-US" sz="950" dirty="0"/>
           </a:p>
@@ -8540,7 +8540,7 @@
                 <a:ea typeface="Arial" pitchFamily="34" charset="-122"/>
                 <a:cs typeface="Arial" pitchFamily="34" charset="-120"/>
               </a:rPr>
-              <a:t>Pró-labore R$ 18.000 · custos fixos R$ 10.000 · guia de impostos R$ 5.841 (11 % das entradas de julho) · repasse à Dra. Renata R$ 4.845 · materiais R$ 1.380 · taxas de cartão R$ 484 · manutenção R$ 450 · despesa pessoal a acertar R$ 620.</a:t>
+              <a:t>Pró-labore R$ 18.000 · custos fixos R$ 10.000 · guia de impostos R$ 5.881 (11 % das entradas de julho) · repasse à Dra. Renata R$ 4.845 · materiais R$ 1.380 · taxas de cartão R$ 484 · manutenção R$ 450 · despesa pessoal a acertar R$ 620.</a:t>
             </a:r>
             <a:endParaRPr lang="en-US" sz="950" dirty="0"/>
           </a:p>
@@ -8581,7 +8581,7 @@
                 <a:ea typeface="Arial" pitchFamily="34" charset="-122"/>
                 <a:cs typeface="Arial" pitchFamily="34" charset="-120"/>
               </a:rPr>
-              <a:t>Sobrou R$ 18.311 de janeiro a agosto; saldo em caixa R$ 52.251 hoje, com R$ 25.997 a pagar até o fim de setembro. Provisão guardada: R$ 17.602 ao fim de agosto. Reserva: R$ 14.000 de R$ 84.000 (meio mês de custo fixo).</a:t>
+              <a:t>Sobrou R$ 18.468 de janeiro a agosto; saldo em caixa R$ 52.758 hoje, com R$ 25.922 a pagar até o fim de setembro. Provisão guardada: R$ 17.527 ao fim de agosto. Reserva: R$ 14.000 de R$ 89.197 (meio mês de custo fixo com pró-labore).</a:t>
             </a:r>
             <a:endParaRPr lang="en-US" sz="950" dirty="0"/>
           </a:p>
@@ -9046,7 +9046,7 @@
                 <a:ea typeface="Arial" pitchFamily="34" charset="-122"/>
                 <a:cs typeface="Arial" pitchFamily="34" charset="-120"/>
               </a:rPr>
-              <a:t>R$ 4.550</a:t>
+              <a:t>R$ 3.775</a:t>
             </a:r>
             <a:endParaRPr lang="en-US" sz="2600" dirty="0"/>
           </a:p>
@@ -9085,7 +9085,7 @@
                 <a:ea typeface="Arial" pitchFamily="34" charset="-122"/>
                 <a:cs typeface="Arial" pitchFamily="34" charset="-120"/>
               </a:rPr>
-              <a:t>Vencido a prazo (10,4 %)</a:t>
+              <a:t>Vencido a prazo (9,4 %)</a:t>
             </a:r>
             <a:endParaRPr lang="en-US" sz="1300" dirty="0"/>
           </a:p>
@@ -9124,7 +9124,7 @@
                 <a:ea typeface="Arial" pitchFamily="34" charset="-122"/>
                 <a:cs typeface="Arial" pitchFamily="34" charset="-120"/>
               </a:rPr>
-              <a:t>16 parcelas; fim de agosto R$ 4.040 (9,8 %); julho R$ 3.380 (9,6 %); meta 8 %</a:t>
+              <a:t>14 parcelas; fim de agosto R$ 4.005 (10,5 %); julho R$ 3.290 (10,0 %); meta 8 %</a:t>
             </a:r>
             <a:endParaRPr lang="en-US" sz="1050" dirty="0"/>
           </a:p>
@@ -9187,7 +9187,7 @@
                 <a:ea typeface="Arial" pitchFamily="34" charset="-122"/>
                 <a:cs typeface="Arial" pitchFamily="34" charset="-120"/>
               </a:rPr>
-              <a:t>Onze parcelas há 30 dias ou mais somam R$ 3.190: mensagem já não resolve; é o degrau 4 da régua (conversa do médico ou da administração e plano por escrito). As outras cinco (R$ 1.360) estão nos degraus 1 a 3, com a recepção.</a:t>
+              <a:t>Doze parcelas há 30 dias ou mais somam R$ 3.455: mensagem já não resolve; é o degrau 4 da régua (conversa do médico ou da administração e plano por escrito). As outras duas (R$ 320, vencidas há menos de uma semana) estão no degrau 1, com a recepção.</a:t>
             </a:r>
             <a:endParaRPr lang="en-US" sz="950" dirty="0"/>
           </a:p>
@@ -9269,7 +9269,7 @@
                 <a:ea typeface="Arial" pitchFamily="34" charset="-122"/>
                 <a:cs typeface="Arial" pitchFamily="34" charset="-120"/>
               </a:rPr>
-              <a:t>Aprovado no trimestre R$ 8.510 (47 % da meta de R$ 18.000); 6 em aberto somando R$ 3.460; taxa de aprovação 72 %; "vai pensar / sem retorno" é o maior motivo de perda.</a:t>
+              <a:t>Aprovado no trimestre R$ 8.960 (50 % da meta de R$ 18.000); 6 em aberto somando R$ 3.460; taxa de aprovação 73 %; "vai pensar / sem retorno" é o maior motivo de perda.</a:t>
             </a:r>
             <a:endParaRPr lang="en-US" sz="950" dirty="0"/>
           </a:p>
@@ -9378,7 +9378,7 @@
                 <a:ea typeface="Arial" pitchFamily="34" charset="-122"/>
                 <a:cs typeface="Arial" pitchFamily="34" charset="-120"/>
               </a:rPr>
-              <a:t>Separar R$ 3.000 por mês para a reserva da clínica, a partir de setembro, até chegar a três meses de custo fixo (R$ 84.000; hoje R$ 14.000, meta em setembro de 2028 pela planilha 12). Ou R$ 5.000, que cabe na sobra média dos três últimos meses fechados (R$ 6.904)?</a:t>
+              <a:t>Separar R$ 3.000 por mês para a reserva da clínica, a partir de setembro, até chegar a três meses de custo fixo com pró-labore (R$ 89.197; hoje R$ 14.000, meta em novembro de 2028 pela planilha 12). Ou R$ 5.000, que cabe na sobra média dos três últimos meses fechados (R$ 6.838)?</a:t>
             </a:r>
             <a:endParaRPr lang="en-US" sz="1300" dirty="0"/>
           </a:p>
@@ -10233,7 +10233,7 @@
                           <a:ea typeface="Arial" pitchFamily="34" charset="-122"/>
                           <a:cs typeface="Arial" pitchFamily="34" charset="-120"/>
                         </a:rPr>
-                        <a:t>Enviar a mensagem da régua para as 16 parcelas vencidas (modelos 09 a 12 do bônus 22) e registrar na planilha 14</a:t>
+                        <a:t>Enviar a mensagem da régua para as 14 parcelas vencidas (modelos 09 a 12 do bônus 22) e registrar na planilha 14</a:t>
                       </a:r>
                       <a:endParaRPr lang="en-US" sz="1000" dirty="0">
                         <a:latin typeface="Arial" charset="0"/>
@@ -10439,7 +10439,7 @@
                           <a:ea typeface="Arial" pitchFamily="34" charset="-122"/>
                           <a:cs typeface="Arial" pitchFamily="34" charset="-120"/>
                         </a:rPr>
-                        <a:t>Conversar com os 11 pacientes com parcela há mais de 30 dias e registrar o plano por escrito</a:t>
+                        <a:t>Conversar com os pacientes das 12 parcelas há mais de 30 dias e registrar o plano por escrito</a:t>
                       </a:r>
                       <a:endParaRPr lang="en-US" sz="1000" dirty="0">
                         <a:latin typeface="Arial" charset="0"/>

</xml_diff>